<commit_message>
Fill all photo slots with CC BY 2.0 photos from Open Images
Source every slot from the Open Images Dataset (Flickr, CC BY 2.0) with
photographer, URL and licence in credits.md plus two alternates per slot.
Strengthen the pillar-panel scrim, add the selection scripts, rebuild the
deck, PDF, previews and contact sheet.

Co-Authored-By: Claude Fable 5.1 <noreply@anthropic.com>
Claude-Session: https://claude.ai/code/session_0159Jrtpw8kkjXiZFjjrvahQ
</commit_message>
<xml_diff>
--- a/master-plan/master-plan.pptx
+++ b/master-plan/master-plan.pptx
@@ -118,19 +118,19 @@
   <p:extLst>
     <p:ext uri="{521415D9-36F7-43E2-AB2F-B90AF26B5E84}">
       <p14:sectionLst xmlns:p14="http://schemas.microsoft.com/office/powerpoint/2010/main">
-        <p14:section name="Opening" id="{aafa1ebf-9692-b682-1700-f5ffaa206ddc}">
+        <p14:section name="Opening" id="{9944ad3f-dc08-7ef9-cdc8-c54328facb29}">
           <p14:sldIdLst>
             <p14:sldId id="256"/>
             <p14:sldId id="257"/>
           </p14:sldIdLst>
         </p14:section>
-        <p14:section name="Where we are" id="{c2bb17c1-8cc5-4c24-17a4-0e747b6c5995}">
+        <p14:section name="Where we are" id="{e00cc6ef-f542-2f53-8bcf-4601016348ff}">
           <p14:sldIdLst>
             <p14:sldId id="258"/>
             <p14:sldId id="259"/>
           </p14:sldIdLst>
         </p14:section>
-        <p14:section name="The plan" id="{6dd9fd7c-22b7-b160-a4a2-0cc75c8357bf}">
+        <p14:section name="The plan" id="{f5a9724e-3850-f7f2-c476-5f6bb12efac3}">
           <p14:sldIdLst>
             <p14:sldId id="260"/>
             <p14:sldId id="261"/>
@@ -139,7 +139,7 @@
             <p14:sldId id="264"/>
           </p14:sldIdLst>
         </p14:section>
-        <p14:section name="The road ahead" id="{d7510521-3842-c7a7-7bf9-2a12582e7706}">
+        <p14:section name="The road ahead" id="{ab52198f-94f4-703f-fabc-3410de8a6d93}">
           <p14:sldIdLst>
             <p14:sldId id="265"/>
             <p14:sldId id="266"/>
@@ -2089,46 +2089,7 @@
       </p:pic>
       <p:sp>
         <p:nvSpPr>
-          <p:cNvPr id="5" name="Photo slot label 01-cover"/>
-          <p:cNvSpPr txBox="1"/>
-          <p:nvPr/>
-        </p:nvSpPr>
-        <p:spPr>
-          <a:xfrm>
-            <a:off x="6080760" y="274320"/>
-            <a:ext cx="5882335" cy="548640"/>
-          </a:xfrm>
-          <a:prstGeom prst="rect">
-            <a:avLst/>
-          </a:prstGeom>
-          <a:noFill/>
-          <a:ln/>
-        </p:spPr>
-        <p:txBody>
-          <a:bodyPr wrap="square" lIns="0" tIns="0" rIns="0" bIns="0" rtlCol="0" anchor="t"/>
-          <a:lstStyle/>
-          <a:p>
-            <a:pPr algn="r" indent="0" marL="0">
-              <a:buNone/>
-            </a:pPr>
-            <a:r>
-              <a:rPr lang="en-US" sz="900" spc="150" kern="0" dirty="0">
-                <a:solidFill>
-                  <a:schemeClr val="accent1"/>
-                </a:solidFill>
-                <a:latin typeface="+mn-lt" pitchFamily="34" charset="0"/>
-                <a:ea typeface="+mn-lt" pitchFamily="34" charset="-122"/>
-                <a:cs typeface="+mn-lt" pitchFamily="34" charset="-120"/>
-              </a:rPr>
-              <a:t>PHOTO SLOT 01-COVER : ROASTED BEANS TUMBLING FROM A DRUM ROASTER</a:t>
-            </a:r>
-            <a:endParaRPr lang="en-US" sz="900" dirty="0"/>
-          </a:p>
-        </p:txBody>
-      </p:sp>
-      <p:sp>
-        <p:nvSpPr>
-          <p:cNvPr id="6" name="Eyebrow: Strategy alignment · Al Shami"/>
+          <p:cNvPr id="5" name="Eyebrow: Strategy alignment · Al Shami"/>
           <p:cNvSpPr txBox="1"/>
           <p:nvPr/>
         </p:nvSpPr>
@@ -2167,7 +2128,7 @@
       </p:sp>
       <p:sp>
         <p:nvSpPr>
-          <p:cNvPr id="7" name="Cover title"/>
+          <p:cNvPr id="6" name="Cover title"/>
           <p:cNvSpPr txBox="1"/>
           <p:nvPr/>
         </p:nvSpPr>
@@ -2206,7 +2167,7 @@
       </p:sp>
       <p:sp>
         <p:nvSpPr>
-          <p:cNvPr id="8" name="Cover subtitle"/>
+          <p:cNvPr id="7" name="Cover subtitle"/>
           <p:cNvSpPr txBox="1"/>
           <p:nvPr/>
         </p:nvSpPr>
@@ -2248,7 +2209,7 @@
       </p:sp>
       <p:sp>
         <p:nvSpPr>
-          <p:cNvPr id="9" name="Cover meta"/>
+          <p:cNvPr id="8" name="Cover meta"/>
           <p:cNvSpPr txBox="1"/>
           <p:nvPr/>
         </p:nvSpPr>
@@ -4030,46 +3991,7 @@
       </p:pic>
       <p:sp>
         <p:nvSpPr>
-          <p:cNvPr id="4" name="Photo slot label 12-close"/>
-          <p:cNvSpPr txBox="1"/>
-          <p:nvPr/>
-        </p:nvSpPr>
-        <p:spPr>
-          <a:xfrm>
-            <a:off x="228600" y="274320"/>
-            <a:ext cx="11734495" cy="548640"/>
-          </a:xfrm>
-          <a:prstGeom prst="rect">
-            <a:avLst/>
-          </a:prstGeom>
-          <a:noFill/>
-          <a:ln/>
-        </p:spPr>
-        <p:txBody>
-          <a:bodyPr wrap="square" lIns="0" tIns="0" rIns="0" bIns="0" rtlCol="0" anchor="t"/>
-          <a:lstStyle/>
-          <a:p>
-            <a:pPr algn="r" indent="0" marL="0">
-              <a:buNone/>
-            </a:pPr>
-            <a:r>
-              <a:rPr lang="en-US" sz="900" spc="150" kern="0" dirty="0">
-                <a:solidFill>
-                  <a:schemeClr val="accent4"/>
-                </a:solidFill>
-                <a:latin typeface="+mn-lt" pitchFamily="34" charset="0"/>
-                <a:ea typeface="+mn-lt" pitchFamily="34" charset="-122"/>
-                <a:cs typeface="+mn-lt" pitchFamily="34" charset="-120"/>
-              </a:rPr>
-              <a:t>PHOTO SLOT 12-CLOSE : STEAM RISING FROM A COFFEE CUP</a:t>
-            </a:r>
-            <a:endParaRPr lang="en-US" sz="900" dirty="0"/>
-          </a:p>
-        </p:txBody>
-      </p:sp>
-      <p:sp>
-        <p:nvSpPr>
-          <p:cNvPr id="5" name="Eyebrow: Thank you"/>
+          <p:cNvPr id="4" name="Eyebrow: Thank you"/>
           <p:cNvSpPr txBox="1"/>
           <p:nvPr/>
         </p:nvSpPr>
@@ -4108,7 +4030,7 @@
       </p:sp>
       <p:sp>
         <p:nvSpPr>
-          <p:cNvPr id="6" name="Statement"/>
+          <p:cNvPr id="5" name="Statement"/>
           <p:cNvSpPr txBox="1"/>
           <p:nvPr/>
         </p:nvSpPr>
@@ -4150,7 +4072,7 @@
       </p:sp>
       <p:sp>
         <p:nvSpPr>
-          <p:cNvPr id="7" name="Contact"/>
+          <p:cNvPr id="6" name="Contact"/>
           <p:cNvSpPr txBox="1"/>
           <p:nvPr/>
         </p:nvSpPr>
@@ -5659,46 +5581,7 @@
       </p:pic>
       <p:sp>
         <p:nvSpPr>
-          <p:cNvPr id="4" name="Photo slot label 04-ambition"/>
-          <p:cNvSpPr txBox="1"/>
-          <p:nvPr/>
-        </p:nvSpPr>
-        <p:spPr>
-          <a:xfrm>
-            <a:off x="228600" y="274320"/>
-            <a:ext cx="11734495" cy="548640"/>
-          </a:xfrm>
-          <a:prstGeom prst="rect">
-            <a:avLst/>
-          </a:prstGeom>
-          <a:noFill/>
-          <a:ln/>
-        </p:spPr>
-        <p:txBody>
-          <a:bodyPr wrap="square" lIns="0" tIns="0" rIns="0" bIns="0" rtlCol="0" anchor="t"/>
-          <a:lstStyle/>
-          <a:p>
-            <a:pPr algn="r" indent="0" marL="0">
-              <a:buNone/>
-            </a:pPr>
-            <a:r>
-              <a:rPr lang="en-US" sz="900" spc="150" kern="0" dirty="0">
-                <a:solidFill>
-                  <a:schemeClr val="accent4"/>
-                </a:solidFill>
-                <a:latin typeface="+mn-lt" pitchFamily="34" charset="0"/>
-                <a:ea typeface="+mn-lt" pitchFamily="34" charset="-122"/>
-                <a:cs typeface="+mn-lt" pitchFamily="34" charset="-120"/>
-              </a:rPr>
-              <a:t>PHOTO SLOT 04-AMBITION : ARABIC COFFEE POURED FROM A BRASS DALLAH</a:t>
-            </a:r>
-            <a:endParaRPr lang="en-US" sz="900" dirty="0"/>
-          </a:p>
-        </p:txBody>
-      </p:sp>
-      <p:sp>
-        <p:nvSpPr>
-          <p:cNvPr id="5" name="Eyebrow: The ambition"/>
+          <p:cNvPr id="4" name="Eyebrow: The ambition"/>
           <p:cNvSpPr txBox="1"/>
           <p:nvPr/>
         </p:nvSpPr>
@@ -5737,7 +5620,7 @@
       </p:sp>
       <p:sp>
         <p:nvSpPr>
-          <p:cNvPr id="6" name="Statement"/>
+          <p:cNvPr id="5" name="Statement"/>
           <p:cNvSpPr txBox="1"/>
           <p:nvPr/>
         </p:nvSpPr>
@@ -5779,7 +5662,7 @@
       </p:sp>
       <p:sp>
         <p:nvSpPr>
-          <p:cNvPr id="7" name="Statement sub"/>
+          <p:cNvPr id="6" name="Statement sub"/>
           <p:cNvSpPr txBox="1"/>
           <p:nvPr/>
         </p:nvSpPr>
@@ -5821,7 +5704,7 @@
       </p:sp>
       <p:sp>
         <p:nvSpPr>
-          <p:cNvPr id="8" name="Footer"/>
+          <p:cNvPr id="7" name="Footer"/>
           <p:cNvSpPr txBox="1"/>
           <p:nvPr/>
         </p:nvSpPr>
@@ -6010,46 +5893,7 @@
       </p:pic>
       <p:sp>
         <p:nvSpPr>
-          <p:cNvPr id="6" name="Photo slot label 05-card-1"/>
-          <p:cNvSpPr txBox="1"/>
-          <p:nvPr/>
-        </p:nvSpPr>
-        <p:spPr>
-          <a:xfrm>
-            <a:off x="1051560" y="2331720"/>
-            <a:ext cx="1950872" cy="548640"/>
-          </a:xfrm>
-          <a:prstGeom prst="rect">
-            <a:avLst/>
-          </a:prstGeom>
-          <a:noFill/>
-          <a:ln/>
-        </p:spPr>
-        <p:txBody>
-          <a:bodyPr wrap="square" lIns="0" tIns="0" rIns="0" bIns="0" rtlCol="0" anchor="t"/>
-          <a:lstStyle/>
-          <a:p>
-            <a:pPr algn="r" indent="0" marL="0">
-              <a:buNone/>
-            </a:pPr>
-            <a:r>
-              <a:rPr lang="en-US" sz="900" spc="150" kern="0" dirty="0">
-                <a:solidFill>
-                  <a:schemeClr val="accent1"/>
-                </a:solidFill>
-                <a:latin typeface="+mn-lt" pitchFamily="34" charset="0"/>
-                <a:ea typeface="+mn-lt" pitchFamily="34" charset="-122"/>
-                <a:cs typeface="+mn-lt" pitchFamily="34" charset="-120"/>
-              </a:rPr>
-              <a:t>PHOTO SLOT 05-CARD-1 : GRAB AND GO COUNTER</a:t>
-            </a:r>
-            <a:endParaRPr lang="en-US" sz="900" dirty="0"/>
-          </a:p>
-        </p:txBody>
-      </p:sp>
-      <p:sp>
-        <p:nvSpPr>
-          <p:cNvPr id="7" name="Pillar number 01"/>
+          <p:cNvPr id="6" name="Pillar number 01"/>
           <p:cNvSpPr txBox="1"/>
           <p:nvPr/>
         </p:nvSpPr>
@@ -6088,7 +5932,7 @@
       </p:sp>
       <p:sp>
         <p:nvSpPr>
-          <p:cNvPr id="8" name="Pillar panel 01"/>
+          <p:cNvPr id="7" name="Pillar panel 01"/>
           <p:cNvSpPr/>
           <p:nvPr/>
         </p:nvSpPr>
@@ -6113,7 +5957,7 @@
       </p:sp>
       <p:sp>
         <p:nvSpPr>
-          <p:cNvPr id="9" name="Pillar title 01"/>
+          <p:cNvPr id="8" name="Pillar title 01"/>
           <p:cNvSpPr txBox="1"/>
           <p:nvPr/>
         </p:nvSpPr>
@@ -6155,7 +5999,7 @@
       </p:sp>
       <p:sp>
         <p:nvSpPr>
-          <p:cNvPr id="10" name="Pillar description 01"/>
+          <p:cNvPr id="9" name="Pillar description 01"/>
           <p:cNvSpPr txBox="1"/>
           <p:nvPr/>
         </p:nvSpPr>
@@ -6197,7 +6041,7 @@
       </p:sp>
       <p:pic>
         <p:nvPicPr>
-          <p:cNvPr id="11" name="Photo 05-card-2" descr="Chef plating in an open kitchen">    </p:cNvPr>
+          <p:cNvPr id="10" name="Photo 05-card-2" descr="Chef plating in an open kitchen">    </p:cNvPr>
           <p:cNvPicPr>
             <a:picLocks noChangeAspect="1"/>
           </p:cNvPicPr>
@@ -6220,7 +6064,7 @@
       </p:pic>
       <p:pic>
         <p:nvPicPr>
-          <p:cNvPr id="12" name="Scrim scrim_bottom" descr="Gradient scrim">    </p:cNvPr>
+          <p:cNvPr id="11" name="Scrim scrim_bottom" descr="Gradient scrim">    </p:cNvPr>
           <p:cNvPicPr>
             <a:picLocks noChangeAspect="1"/>
           </p:cNvPicPr>
@@ -6244,46 +6088,7 @@
       </p:pic>
       <p:sp>
         <p:nvSpPr>
-          <p:cNvPr id="13" name="Photo slot label 05-card-2"/>
-          <p:cNvSpPr txBox="1"/>
-          <p:nvPr/>
-        </p:nvSpPr>
-        <p:spPr>
-          <a:xfrm>
-            <a:off x="3764128" y="2331720"/>
-            <a:ext cx="1950872" cy="548640"/>
-          </a:xfrm>
-          <a:prstGeom prst="rect">
-            <a:avLst/>
-          </a:prstGeom>
-          <a:noFill/>
-          <a:ln/>
-        </p:spPr>
-        <p:txBody>
-          <a:bodyPr wrap="square" lIns="0" tIns="0" rIns="0" bIns="0" rtlCol="0" anchor="t"/>
-          <a:lstStyle/>
-          <a:p>
-            <a:pPr algn="r" indent="0" marL="0">
-              <a:buNone/>
-            </a:pPr>
-            <a:r>
-              <a:rPr lang="en-US" sz="900" spc="150" kern="0" dirty="0">
-                <a:solidFill>
-                  <a:schemeClr val="accent1"/>
-                </a:solidFill>
-                <a:latin typeface="+mn-lt" pitchFamily="34" charset="0"/>
-                <a:ea typeface="+mn-lt" pitchFamily="34" charset="-122"/>
-                <a:cs typeface="+mn-lt" pitchFamily="34" charset="-120"/>
-              </a:rPr>
-              <a:t>PHOTO SLOT 05-CARD-2 : CHEF PLATING IN AN OPEN KITCHEN</a:t>
-            </a:r>
-            <a:endParaRPr lang="en-US" sz="900" dirty="0"/>
-          </a:p>
-        </p:txBody>
-      </p:sp>
-      <p:sp>
-        <p:nvSpPr>
-          <p:cNvPr id="14" name="Pillar number 02"/>
+          <p:cNvPr id="12" name="Pillar number 02"/>
           <p:cNvSpPr txBox="1"/>
           <p:nvPr/>
         </p:nvSpPr>
@@ -6322,7 +6127,7 @@
       </p:sp>
       <p:sp>
         <p:nvSpPr>
-          <p:cNvPr id="15" name="Pillar panel 02"/>
+          <p:cNvPr id="13" name="Pillar panel 02"/>
           <p:cNvSpPr/>
           <p:nvPr/>
         </p:nvSpPr>
@@ -6347,7 +6152,7 @@
       </p:sp>
       <p:sp>
         <p:nvSpPr>
-          <p:cNvPr id="16" name="Pillar title 02"/>
+          <p:cNvPr id="14" name="Pillar title 02"/>
           <p:cNvSpPr txBox="1"/>
           <p:nvPr/>
         </p:nvSpPr>
@@ -6389,7 +6194,7 @@
       </p:sp>
       <p:sp>
         <p:nvSpPr>
-          <p:cNvPr id="17" name="Pillar description 02"/>
+          <p:cNvPr id="15" name="Pillar description 02"/>
           <p:cNvSpPr txBox="1"/>
           <p:nvPr/>
         </p:nvSpPr>
@@ -6431,7 +6236,7 @@
       </p:sp>
       <p:pic>
         <p:nvPicPr>
-          <p:cNvPr id="18" name="Photo 05-card-3" descr="Resort terrace at sunset">    </p:cNvPr>
+          <p:cNvPr id="16" name="Photo 05-card-3" descr="Resort terrace at sunset">    </p:cNvPr>
           <p:cNvPicPr>
             <a:picLocks noChangeAspect="1"/>
           </p:cNvPicPr>
@@ -6454,7 +6259,7 @@
       </p:pic>
       <p:pic>
         <p:nvPicPr>
-          <p:cNvPr id="19" name="Scrim scrim_bottom" descr="Gradient scrim">    </p:cNvPr>
+          <p:cNvPr id="17" name="Scrim scrim_bottom" descr="Gradient scrim">    </p:cNvPr>
           <p:cNvPicPr>
             <a:picLocks noChangeAspect="1"/>
           </p:cNvPicPr>
@@ -6478,46 +6283,7 @@
       </p:pic>
       <p:sp>
         <p:nvSpPr>
-          <p:cNvPr id="20" name="Photo slot label 05-card-3"/>
-          <p:cNvSpPr txBox="1"/>
-          <p:nvPr/>
-        </p:nvSpPr>
-        <p:spPr>
-          <a:xfrm>
-            <a:off x="6476695" y="2331720"/>
-            <a:ext cx="1950872" cy="548640"/>
-          </a:xfrm>
-          <a:prstGeom prst="rect">
-            <a:avLst/>
-          </a:prstGeom>
-          <a:noFill/>
-          <a:ln/>
-        </p:spPr>
-        <p:txBody>
-          <a:bodyPr wrap="square" lIns="0" tIns="0" rIns="0" bIns="0" rtlCol="0" anchor="t"/>
-          <a:lstStyle/>
-          <a:p>
-            <a:pPr algn="r" indent="0" marL="0">
-              <a:buNone/>
-            </a:pPr>
-            <a:r>
-              <a:rPr lang="en-US" sz="900" spc="150" kern="0" dirty="0">
-                <a:solidFill>
-                  <a:schemeClr val="accent1"/>
-                </a:solidFill>
-                <a:latin typeface="+mn-lt" pitchFamily="34" charset="0"/>
-                <a:ea typeface="+mn-lt" pitchFamily="34" charset="-122"/>
-                <a:cs typeface="+mn-lt" pitchFamily="34" charset="-120"/>
-              </a:rPr>
-              <a:t>PHOTO SLOT 05-CARD-3 : RESORT TERRACE AT SUNSET</a:t>
-            </a:r>
-            <a:endParaRPr lang="en-US" sz="900" dirty="0"/>
-          </a:p>
-        </p:txBody>
-      </p:sp>
-      <p:sp>
-        <p:nvSpPr>
-          <p:cNvPr id="21" name="Pillar number 03"/>
+          <p:cNvPr id="18" name="Pillar number 03"/>
           <p:cNvSpPr txBox="1"/>
           <p:nvPr/>
         </p:nvSpPr>
@@ -6556,7 +6322,7 @@
       </p:sp>
       <p:sp>
         <p:nvSpPr>
-          <p:cNvPr id="22" name="Pillar panel 03"/>
+          <p:cNvPr id="19" name="Pillar panel 03"/>
           <p:cNvSpPr/>
           <p:nvPr/>
         </p:nvSpPr>
@@ -6581,7 +6347,7 @@
       </p:sp>
       <p:sp>
         <p:nvSpPr>
-          <p:cNvPr id="23" name="Pillar title 03"/>
+          <p:cNvPr id="20" name="Pillar title 03"/>
           <p:cNvSpPr txBox="1"/>
           <p:nvPr/>
         </p:nvSpPr>
@@ -6623,7 +6389,7 @@
       </p:sp>
       <p:sp>
         <p:nvSpPr>
-          <p:cNvPr id="24" name="Pillar description 03"/>
+          <p:cNvPr id="21" name="Pillar description 03"/>
           <p:cNvSpPr txBox="1"/>
           <p:nvPr/>
         </p:nvSpPr>
@@ -6665,7 +6431,7 @@
       </p:sp>
       <p:pic>
         <p:nvPicPr>
-          <p:cNvPr id="25" name="Photo 05-card-4" descr="Hands holding a small cup of cardamom coffee">    </p:cNvPr>
+          <p:cNvPr id="22" name="Photo 05-card-4" descr="Hands holding a small cup of cardamom coffee">    </p:cNvPr>
           <p:cNvPicPr>
             <a:picLocks noChangeAspect="1"/>
           </p:cNvPicPr>
@@ -6688,7 +6454,7 @@
       </p:pic>
       <p:pic>
         <p:nvPicPr>
-          <p:cNvPr id="26" name="Scrim scrim_bottom" descr="Gradient scrim">    </p:cNvPr>
+          <p:cNvPr id="23" name="Scrim scrim_bottom" descr="Gradient scrim">    </p:cNvPr>
           <p:cNvPicPr>
             <a:picLocks noChangeAspect="1"/>
           </p:cNvPicPr>
@@ -6712,46 +6478,7 @@
       </p:pic>
       <p:sp>
         <p:nvSpPr>
-          <p:cNvPr id="27" name="Photo slot label 05-card-4"/>
-          <p:cNvSpPr txBox="1"/>
-          <p:nvPr/>
-        </p:nvSpPr>
-        <p:spPr>
-          <a:xfrm>
-            <a:off x="9189263" y="2331720"/>
-            <a:ext cx="1950872" cy="548640"/>
-          </a:xfrm>
-          <a:prstGeom prst="rect">
-            <a:avLst/>
-          </a:prstGeom>
-          <a:noFill/>
-          <a:ln/>
-        </p:spPr>
-        <p:txBody>
-          <a:bodyPr wrap="square" lIns="0" tIns="0" rIns="0" bIns="0" rtlCol="0" anchor="t"/>
-          <a:lstStyle/>
-          <a:p>
-            <a:pPr algn="r" indent="0" marL="0">
-              <a:buNone/>
-            </a:pPr>
-            <a:r>
-              <a:rPr lang="en-US" sz="900" spc="150" kern="0" dirty="0">
-                <a:solidFill>
-                  <a:schemeClr val="accent1"/>
-                </a:solidFill>
-                <a:latin typeface="+mn-lt" pitchFamily="34" charset="0"/>
-                <a:ea typeface="+mn-lt" pitchFamily="34" charset="-122"/>
-                <a:cs typeface="+mn-lt" pitchFamily="34" charset="-120"/>
-              </a:rPr>
-              <a:t>PHOTO SLOT 05-CARD-4 : HANDS HOLDING A SMALL CUP OF CARDAMOM COFFEE</a:t>
-            </a:r>
-            <a:endParaRPr lang="en-US" sz="900" dirty="0"/>
-          </a:p>
-        </p:txBody>
-      </p:sp>
-      <p:sp>
-        <p:nvSpPr>
-          <p:cNvPr id="28" name="Pillar number 04"/>
+          <p:cNvPr id="24" name="Pillar number 04"/>
           <p:cNvSpPr txBox="1"/>
           <p:nvPr/>
         </p:nvSpPr>
@@ -6790,7 +6517,7 @@
       </p:sp>
       <p:sp>
         <p:nvSpPr>
-          <p:cNvPr id="29" name="Pillar panel 04"/>
+          <p:cNvPr id="25" name="Pillar panel 04"/>
           <p:cNvSpPr/>
           <p:nvPr/>
         </p:nvSpPr>
@@ -6815,7 +6542,7 @@
       </p:sp>
       <p:sp>
         <p:nvSpPr>
-          <p:cNvPr id="30" name="Pillar title 04"/>
+          <p:cNvPr id="26" name="Pillar title 04"/>
           <p:cNvSpPr txBox="1"/>
           <p:nvPr/>
         </p:nvSpPr>
@@ -6857,7 +6584,7 @@
       </p:sp>
       <p:sp>
         <p:nvSpPr>
-          <p:cNvPr id="31" name="Pillar description 04"/>
+          <p:cNvPr id="27" name="Pillar description 04"/>
           <p:cNvSpPr txBox="1"/>
           <p:nvPr/>
         </p:nvSpPr>
@@ -6899,7 +6626,7 @@
       </p:sp>
       <p:sp>
         <p:nvSpPr>
-          <p:cNvPr id="32" name="Footer"/>
+          <p:cNvPr id="28" name="Footer"/>
           <p:cNvSpPr txBox="1"/>
           <p:nvPr/>
         </p:nvSpPr>
@@ -7008,45 +6735,30 @@
           </a:prstGeom>
         </p:spPr>
       </p:pic>
-      <p:sp>
-        <p:nvSpPr>
-          <p:cNvPr id="4" name="Photo slot label 06-pillar-1"/>
-          <p:cNvSpPr txBox="1"/>
-          <p:nvPr/>
-        </p:nvSpPr>
-        <p:spPr>
-          <a:xfrm>
-            <a:off x="228600" y="274320"/>
-            <a:ext cx="4419478" cy="548640"/>
-          </a:xfrm>
-          <a:prstGeom prst="rect">
-            <a:avLst/>
-          </a:prstGeom>
-          <a:noFill/>
-          <a:ln/>
-        </p:spPr>
-        <p:txBody>
-          <a:bodyPr wrap="square" lIns="0" tIns="0" rIns="0" bIns="0" rtlCol="0" anchor="t"/>
-          <a:lstStyle/>
-          <a:p>
-            <a:pPr algn="r" indent="0" marL="0">
-              <a:buNone/>
-            </a:pPr>
-            <a:r>
-              <a:rPr lang="en-US" sz="900" spc="150" kern="0" dirty="0">
-                <a:solidFill>
-                  <a:schemeClr val="accent1"/>
-                </a:solidFill>
-                <a:latin typeface="+mn-lt" pitchFamily="34" charset="0"/>
-                <a:ea typeface="+mn-lt" pitchFamily="34" charset="-122"/>
-                <a:cs typeface="+mn-lt" pitchFamily="34" charset="-120"/>
-              </a:rPr>
-              <a:t>PHOTO SLOT 06-PILLAR-1 : ROASTERY WITH BURLAP SACKS</a:t>
-            </a:r>
-            <a:endParaRPr lang="en-US" sz="900" dirty="0"/>
-          </a:p>
-        </p:txBody>
-      </p:sp>
+      <p:pic>
+        <p:nvPicPr>
+          <p:cNvPr id="4" name="Scrim scrim_left_fade_soft" descr="Gradient scrim">    </p:cNvPr>
+          <p:cNvPicPr>
+            <a:picLocks noChangeAspect="1"/>
+          </p:cNvPicPr>
+          <p:nvPr/>
+        </p:nvPicPr>
+        <p:blipFill>
+          <a:blip r:embed="rId3"/>
+          <a:stretch>
+            <a:fillRect/>
+          </a:stretch>
+        </p:blipFill>
+        <p:spPr>
+          <a:xfrm>
+            <a:off x="0" y="0"/>
+            <a:ext cx="4876678" cy="6858000"/>
+          </a:xfrm>
+          <a:prstGeom prst="rect">
+            <a:avLst/>
+          </a:prstGeom>
+        </p:spPr>
+      </p:pic>
       <p:sp>
         <p:nvSpPr>
           <p:cNvPr id="5" name="Eyebrow: Pillar 01"/>
@@ -8105,45 +7817,30 @@
           </a:prstGeom>
         </p:spPr>
       </p:pic>
-      <p:sp>
-        <p:nvSpPr>
-          <p:cNvPr id="4" name="Photo slot label 07-pillar-2"/>
-          <p:cNvSpPr txBox="1"/>
-          <p:nvPr/>
-        </p:nvSpPr>
-        <p:spPr>
-          <a:xfrm>
-            <a:off x="228600" y="274320"/>
-            <a:ext cx="4419478" cy="548640"/>
-          </a:xfrm>
-          <a:prstGeom prst="rect">
-            <a:avLst/>
-          </a:prstGeom>
-          <a:noFill/>
-          <a:ln/>
-        </p:spPr>
-        <p:txBody>
-          <a:bodyPr wrap="square" lIns="0" tIns="0" rIns="0" bIns="0" rtlCol="0" anchor="t"/>
-          <a:lstStyle/>
-          <a:p>
-            <a:pPr algn="r" indent="0" marL="0">
-              <a:buNone/>
-            </a:pPr>
-            <a:r>
-              <a:rPr lang="en-US" sz="900" spc="150" kern="0" dirty="0">
-                <a:solidFill>
-                  <a:schemeClr val="accent1"/>
-                </a:solidFill>
-                <a:latin typeface="+mn-lt" pitchFamily="34" charset="0"/>
-                <a:ea typeface="+mn-lt" pitchFamily="34" charset="-122"/>
-                <a:cs typeface="+mn-lt" pitchFamily="34" charset="-120"/>
-              </a:rPr>
-              <a:t>PHOTO SLOT 07-PILLAR-2 : CHEF PLATING AT A PASS</a:t>
-            </a:r>
-            <a:endParaRPr lang="en-US" sz="900" dirty="0"/>
-          </a:p>
-        </p:txBody>
-      </p:sp>
+      <p:pic>
+        <p:nvPicPr>
+          <p:cNvPr id="4" name="Scrim scrim_left_fade_soft" descr="Gradient scrim">    </p:cNvPr>
+          <p:cNvPicPr>
+            <a:picLocks noChangeAspect="1"/>
+          </p:cNvPicPr>
+          <p:nvPr/>
+        </p:nvPicPr>
+        <p:blipFill>
+          <a:blip r:embed="rId3"/>
+          <a:stretch>
+            <a:fillRect/>
+          </a:stretch>
+        </p:blipFill>
+        <p:spPr>
+          <a:xfrm>
+            <a:off x="0" y="0"/>
+            <a:ext cx="4876678" cy="6858000"/>
+          </a:xfrm>
+          <a:prstGeom prst="rect">
+            <a:avLst/>
+          </a:prstGeom>
+        </p:spPr>
+      </p:pic>
       <p:sp>
         <p:nvSpPr>
           <p:cNvPr id="5" name="Eyebrow: Pillar 02"/>
@@ -9202,45 +8899,30 @@
           </a:prstGeom>
         </p:spPr>
       </p:pic>
-      <p:sp>
-        <p:nvSpPr>
-          <p:cNvPr id="4" name="Photo slot label 08-pillar-3"/>
-          <p:cNvSpPr txBox="1"/>
-          <p:nvPr/>
-        </p:nvSpPr>
-        <p:spPr>
-          <a:xfrm>
-            <a:off x="228600" y="274320"/>
-            <a:ext cx="4419478" cy="548640"/>
-          </a:xfrm>
-          <a:prstGeom prst="rect">
-            <a:avLst/>
-          </a:prstGeom>
-          <a:noFill/>
-          <a:ln/>
-        </p:spPr>
-        <p:txBody>
-          <a:bodyPr wrap="square" lIns="0" tIns="0" rIns="0" bIns="0" rtlCol="0" anchor="t"/>
-          <a:lstStyle/>
-          <a:p>
-            <a:pPr algn="r" indent="0" marL="0">
-              <a:buNone/>
-            </a:pPr>
-            <a:r>
-              <a:rPr lang="en-US" sz="900" spc="150" kern="0" dirty="0">
-                <a:solidFill>
-                  <a:schemeClr val="accent1"/>
-                </a:solidFill>
-                <a:latin typeface="+mn-lt" pitchFamily="34" charset="0"/>
-                <a:ea typeface="+mn-lt" pitchFamily="34" charset="-122"/>
-                <a:cs typeface="+mn-lt" pitchFamily="34" charset="-120"/>
-              </a:rPr>
-              <a:t>PHOTO SLOT 08-PILLAR-3 : RESORT COURTYARD, LANTERNS AT DUSK</a:t>
-            </a:r>
-            <a:endParaRPr lang="en-US" sz="900" dirty="0"/>
-          </a:p>
-        </p:txBody>
-      </p:sp>
+      <p:pic>
+        <p:nvPicPr>
+          <p:cNvPr id="4" name="Scrim scrim_left_fade_soft" descr="Gradient scrim">    </p:cNvPr>
+          <p:cNvPicPr>
+            <a:picLocks noChangeAspect="1"/>
+          </p:cNvPicPr>
+          <p:nvPr/>
+        </p:nvPicPr>
+        <p:blipFill>
+          <a:blip r:embed="rId3"/>
+          <a:stretch>
+            <a:fillRect/>
+          </a:stretch>
+        </p:blipFill>
+        <p:spPr>
+          <a:xfrm>
+            <a:off x="0" y="0"/>
+            <a:ext cx="4876678" cy="6858000"/>
+          </a:xfrm>
+          <a:prstGeom prst="rect">
+            <a:avLst/>
+          </a:prstGeom>
+        </p:spPr>
+      </p:pic>
       <p:sp>
         <p:nvSpPr>
           <p:cNvPr id="5" name="Eyebrow: Pillar 03"/>
@@ -10299,45 +9981,30 @@
           </a:prstGeom>
         </p:spPr>
       </p:pic>
-      <p:sp>
-        <p:nvSpPr>
-          <p:cNvPr id="4" name="Photo slot label 09-pillar-4"/>
-          <p:cNvSpPr txBox="1"/>
-          <p:nvPr/>
-        </p:nvSpPr>
-        <p:spPr>
-          <a:xfrm>
-            <a:off x="228600" y="274320"/>
-            <a:ext cx="4419478" cy="548640"/>
-          </a:xfrm>
-          <a:prstGeom prst="rect">
-            <a:avLst/>
-          </a:prstGeom>
-          <a:noFill/>
-          <a:ln/>
-        </p:spPr>
-        <p:txBody>
-          <a:bodyPr wrap="square" lIns="0" tIns="0" rIns="0" bIns="0" rtlCol="0" anchor="t"/>
-          <a:lstStyle/>
-          <a:p>
-            <a:pPr algn="r" indent="0" marL="0">
-              <a:buNone/>
-            </a:pPr>
-            <a:r>
-              <a:rPr lang="en-US" sz="900" spc="150" kern="0" dirty="0">
-                <a:solidFill>
-                  <a:schemeClr val="accent1"/>
-                </a:solidFill>
-                <a:latin typeface="+mn-lt" pitchFamily="34" charset="0"/>
-                <a:ea typeface="+mn-lt" pitchFamily="34" charset="-122"/>
-                <a:cs typeface="+mn-lt" pitchFamily="34" charset="-120"/>
-              </a:rPr>
-              <a:t>PHOTO SLOT 09-PILLAR-4 : HERITAGE COFFEE HOUSE, BRASS AND WOOD</a:t>
-            </a:r>
-            <a:endParaRPr lang="en-US" sz="900" dirty="0"/>
-          </a:p>
-        </p:txBody>
-      </p:sp>
+      <p:pic>
+        <p:nvPicPr>
+          <p:cNvPr id="4" name="Scrim scrim_left_fade_soft" descr="Gradient scrim">    </p:cNvPr>
+          <p:cNvPicPr>
+            <a:picLocks noChangeAspect="1"/>
+          </p:cNvPicPr>
+          <p:nvPr/>
+        </p:nvPicPr>
+        <p:blipFill>
+          <a:blip r:embed="rId3"/>
+          <a:stretch>
+            <a:fillRect/>
+          </a:stretch>
+        </p:blipFill>
+        <p:spPr>
+          <a:xfrm>
+            <a:off x="0" y="0"/>
+            <a:ext cx="4876678" cy="6858000"/>
+          </a:xfrm>
+          <a:prstGeom prst="rect">
+            <a:avLst/>
+          </a:prstGeom>
+        </p:spPr>
+      </p:pic>
       <p:sp>
         <p:nvSpPr>
           <p:cNvPr id="5" name="Eyebrow: Pillar 04"/>

</xml_diff>